<commit_message>
lecture: replan to 35 min content + 10 min Q&A; add demo kit
- Roadmap now 10/7/13/5 + fixed 10-min Q&A block; all speaker-note
  timings rebalanced (content sums ~32.5 min, ~2.5 min slack)
- lecture/demo/: AGENTS.md (the walkthrough contract shown on slide 11),
  demo-script.md (pre-flight checklist, kickoff prompt, narration beats,
  timing guard, no-network fallback), shortlist-template.md (target
  output format)
- fix stale 'workshop repo' resource line -> lecture lives in this repo
- re-rendered HTML/PDF/PPTX; footer-check PASS (19 slides)
</commit_message>
<xml_diff>
--- a/lecture/agentic-ai-for-lead-generation.pptx
+++ b/lecture/agentic-ai-for-lead-generation.pptx
@@ -521,7 +521,7 @@
             <a:r>
               <a:rPr lang="en-US" dirty="0"/>
               <a:t>notes:
-(1 min) Welcome. What this lecture is: what agentic AI is, and how
+(45 s) Welcome. What this lecture is: what agentic AI is, and how
 to operate it through a harness. Everything we do maps to one real
 task: helping the chair find and qualify B2B partner companies.
 The output of this session is the input for the Bachelor seminar.</a:t>
@@ -704,9 +704,10 @@
             <a:r>
               <a:rPr lang="en-US" dirty="0"/>
               <a:t>notes:
-(2 min) Show the contract as the first artifact. The students see that
-"prompting" an agent starts with writing rules, not typing a question.
-This slide is the live file on screen.</a:t>
+(2 min) Show the contract as the first artifact — the live file is
+lecture/demo/AGENTS.md in this repo. The students see that "prompting"
+an agent starts with writing rules, not typing a question. Full demo
+narration + kickoff prompt: lecture/demo/demo-script.md.</a:t>
             </a:r>
             <a:endParaRPr lang="en-US" dirty="0"/>
           </a:p>
@@ -795,7 +796,7 @@
             <a:r>
               <a:rPr lang="en-US" dirty="0"/>
               <a:t>notes:
-(6-8 min) THE core demo. Run the analysis loop live in pi. Narrate:
+(8 min) THE core demo. Run the analysis loop live in pi. Narrate:
 (1) it opens the browser via MCP/BrowserMCP, searches for prospect
 companies; (2) it reads real pages and extracts fit signals; (3) it
 scores against the contract; (4) it writes a markdown table with URLs;
@@ -1076,7 +1077,7 @@
             <a:r>
               <a:rPr lang="en-US" dirty="0"/>
               <a:t>notes:
-(2 min) Make the value exchange explicit — why the chair invested in
+(1.5 min) Make the value exchange explicit — why the chair invested in
 this guest lecture. Also honest note: the method is open and reusable;
 students may embed it in internships and theses.</a:t>
             </a:r>
@@ -1167,7 +1168,7 @@
             <a:r>
               <a:rPr lang="en-US" dirty="0"/>
               <a:t>notes:
-(2 min) Practical slide — what students can use NOW. Lead with the
+(1.5 min) Practical slide — what students can use NOW. Lead with the
 JLU HRZ API-Service: LLM endpoints for all JLU members, open-source
 (qwen3-coder-next 256K, qwen3.8-27b 1M) and commercial models; access
 by emailing ki@uni-giessen.de; configured in OpenCode via LiteLLM
@@ -1455,7 +1456,7 @@
             <a:r>
               <a:rPr lang="en-US" dirty="0"/>
               <a:t>notes:
-(5-10 min) Q&amp;A + apply the three questions to the walkthrough result.
+(10 min) Q&amp;A + apply the three questions to the walkthrough result.
 Likely questions: model choice (harness is model-agnostic; pi switches
 model with Ctrl+L), costs (cheap models + tight contracts), data
 privacy (local models), what "qualified" means (the contract), and how
@@ -1548,7 +1549,7 @@
             <a:r>
               <a:rPr lang="en-US" dirty="0"/>
               <a:t>notes:
-(1 min) Concrete goal for the students: by the end you can RECOGNISE
+(45 s) Concrete goal for the students: by the end you can RECOGNISE
 and judge an agentic workflow — and read the contract that drives it.
 The artefact shown in the walkthrough (a ranked lead list with sources)
 becomes the working dataset the Bachelor students build on.</a:t>
@@ -1732,7 +1733,8 @@
               <a:rPr lang="en-US" dirty="0"/>
               <a:t>notes:
 (15 s) Show the arc; the walkthrough (block 3) is where the method
-becomes visible. Q&amp;A stays flexible at the end.</a:t>
+becomes visible. Q&amp;A is a fixed 10-minute block at the end — bank
+questions during the talk ("hold that for Q&amp;A") to protect the timing.</a:t>
             </a:r>
             <a:endParaRPr lang="en-US" dirty="0"/>
           </a:p>
@@ -1821,7 +1823,7 @@
             <a:r>
               <a:rPr lang="en-US" dirty="0"/>
               <a:t>notes:
-(3 min) Left: chat — question in, answer out, no tools, no files.
+(2.5 min) Left: chat — question in, answer out, no tools, no files.
 Right: agent — a goal, a plan, tools, verification, inside a harness
 that grants access. The amber loop is where the work happens.
 The students' common misconception: "agentic = a smarter ChatGPT".
@@ -1915,7 +1917,7 @@
             <a:r>
               <a:rPr lang="en-US" dirty="0"/>
               <a:t>notes:
-(3 min) Keep it simple. The model is the part students already know.
+(2.5 min) Keep it simple. The model is the part students already know.
 The harness is the missing piece this lecture adds: an executable
 environment (terminal, browser, files) + permissions + memory.
 The loop is what makes it "agentic": it iterates, checks, corrects.</a:t>

</xml_diff>

<commit_message>
lecture: deslop pass — fix SVG geometry bugs, stale wording, timing sync
SVG fixes:
- leadgen-pipeline: box-2 sub-label overflowed its box -> 'pages,
  events, news'; step labels 19px -> 17px (QUALIFY/RECORD kissed border)
- contract-vs-prompt: 'pass -> done' sat on the arrow line -> moved right
- model-harness-loop: two floating arcs -> proper brain silhouette + curls

Deck deslop:
- 'Your output' / 'your shortlist' -> demo's output (walkthrough format)
- 'what the agents do' -> 'what the agent does'; 'demoed' -> 'from the demo'
- dedupe 'Done means' blockquote on consecutive slides
- drop dead fallback comment block; 'incl. HRZ' clarified

Demo kit: fallback-session.md now a pre-flight TODO (file is created
before the talk, not referenced as existing). lecture/README + root
README pointer synced to 35+10 timing.
</commit_message>
<xml_diff>
--- a/lecture/agentic-ai-for-lead-generation.pptx
+++ b/lecture/agentic-ai-for-lead-generation.pptx
@@ -2199,15 +2199,7 @@
 the middle four; the human sets criteria and judges the result. The
 amber feedback line: learned data tightens the next iteration's
 criteria. This exact pipeline is what the walkthrough demonstrates
-live in the next block.
-fallback: keep the step text for PDF/print contexts if the SVG
-is unavailable.
-1  DEFINE   → ICP for the chair's partner programme
-2  SOURCE   → browser + search: prospects, events, funding
-3  QUALIFY  → score company vs ICP (fit signals, evidence)
-4  RECORD   → every claim with a URL, save as data
-5  VERIFY   → citations resolve, no invented facts
-6  OUTPUT   → ranked shortlist → Bachelor seminar input</a:t>
+live in the next block.</a:t>
             </a:r>
             <a:endParaRPr lang="en-US" dirty="0"/>
           </a:p>

</xml_diff>

<commit_message>
lecture: hone pass — correct corpus stat (agentic×lead-gen intersection is 0, not 5), sharper claims, verified provider facts against HRZ/Google sources
</commit_message>
<xml_diff>
--- a/lecture/agentic-ai-for-lead-generation.pptx
+++ b/lecture/agentic-ai-for-lead-generation.pptx
@@ -1734,7 +1734,9 @@
               <a:t>notes:
 (15 s) Show the arc; the walkthrough (block 3) is where the method
 becomes visible. Q&amp;A is a fixed 10-minute block at the end — bank
-questions during the talk ("hold that for Q&amp;A") to protect the timing.</a:t>
+questions during the talk ("hold that for Q&amp;A") to protect the timing.
+The per-slide notes sum to ~32 min; the remaining ~3 min are buffer
+for transitions and demo hiccups.</a:t>
             </a:r>
             <a:endParaRPr lang="en-US" dirty="0"/>
           </a:p>
@@ -2011,9 +2013,10 @@
               <a:t>notes:
 (2 min) Ground the hype in data from the chair's own open research
 corpus (marketing-research, public on GitHub). Agentic papers exist,
-lead-gen papers exist, but nearly nobody connects both yet. This is
-a research gap AND a practical opportunity. Number on screen: 2026
-alone produced 7,771 of the 13,096 papers.</a:t>
+lead-gen papers exist, but the intersection is literally ZERO. Say
+that number out loud — it lands harder than "nearly nobody": a
+research gap AND a practical opportunity. 2026 alone produced 7,771
+of the 13,096 papers.</a:t>
             </a:r>
             <a:endParaRPr lang="en-US" dirty="0"/>
           </a:p>

</xml_diff>

<commit_message>
lecture: hone pass 2 — roadmap timings match speaker notes (8/6/14/5), concrete harness line, on-slide expectation 'live: 2 of 10'
</commit_message>
<xml_diff>
--- a/lecture/agentic-ai-for-lead-generation.pptx
+++ b/lecture/agentic-ai-for-lead-generation.pptx
@@ -1735,8 +1735,8 @@
 (15 s) Show the arc; the walkthrough (block 3) is where the method
 becomes visible. Q&amp;A is a fixed 10-minute block at the end — bank
 questions during the talk ("hold that for Q&amp;A") to protect the timing.
-The per-slide notes sum to ~32 min; the remaining ~3 min are buffer
-for transitions and demo hiccups.</a:t>
+The per-slide notes sum to ~32 min; the gap to 35 is deliberate
+buffer for transitions and demo hiccups.</a:t>
             </a:r>
             <a:endParaRPr lang="en-US" dirty="0"/>
           </a:p>

</xml_diff>